<commit_message>
Them ban slide 5 trang du phong + script sinh slide tu so lieu that
- scripts/make_slide.py: sinh ca hai ban slide, doc so truc tiep tu
  artifacts/*/metrics.json nen khong bao gio lech khoi ket qua that
- docs/slide-cach-lam-5-trang.pptx: 5 trang de trinh bay
    1. Bai toan va pham vi (thay giao gi / da lam gi)
    2. Cach lam 1/3: kien truc 3 tang + 3 nguyen tac
    3. Cach lam 2/3: quy trinh 5 buoc + 3 van de da xu ly
    4. Cach lam 3/3: ket qua 4 chuc nang, bang so + 4 anh chup man hinh
    5. So do, kiem thu, khai bao AI, han che da biet
- docs/slide-cach-lam.pptx: giu dung 1 trang theo nguyen van yeu cau,
  nay sinh bang script nen so tren slide luon khop artifacts/

Khong doi noi dung giao dien hay backend.
</commit_message>
<xml_diff>
--- a/docs/slide-cach-lam.pptx
+++ b/docs/slide-cach-lam.pptx
@@ -3090,874 +3090,25 @@
       <p:grpSpPr/>
       <p:sp>
         <p:nvSpPr>
-          <p:cNvPr id="2" name="TextBox 1"/>
-          <p:cNvSpPr txBox="1"/>
+          <p:cNvPr id="2" name="Rectangle 1"/>
+          <p:cNvSpPr/>
           <p:nvPr/>
         </p:nvSpPr>
         <p:spPr>
           <a:xfrm>
-            <a:off x="457200" y="256032"/>
-            <a:ext cx="11247120" cy="548640"/>
-          </a:xfrm>
-          <a:prstGeom prst="rect">
-            <a:avLst/>
-          </a:prstGeom>
-          <a:noFill/>
-        </p:spPr>
-        <p:txBody>
-          <a:bodyPr wrap="square">
-            <a:spAutoFit/>
-          </a:bodyPr>
-          <a:lstStyle/>
-          <a:p>
-            <a:pPr algn="l">
-              <a:spcAft>
-                <a:spcPts val="400"/>
-              </a:spcAft>
-            </a:pPr>
-            <a:r>
-              <a:rPr sz="2400" b="1">
-                <a:solidFill>
-                  <a:srgbClr val="0B6E99"/>
-                </a:solidFill>
-              </a:rPr>
-              <a:t>AI Web Apps — 4 chức năng AI sau một backend FastAPI</a:t>
-            </a:r>
-          </a:p>
-        </p:txBody>
-      </p:sp>
-      <p:sp>
-        <p:nvSpPr>
-          <p:cNvPr id="3" name="TextBox 2"/>
-          <p:cNvSpPr txBox="1"/>
-          <p:nvPr/>
-        </p:nvSpPr>
-        <p:spPr>
-          <a:xfrm>
-            <a:off x="457200" y="804672"/>
-            <a:ext cx="11247120" cy="274320"/>
-          </a:xfrm>
-          <a:prstGeom prst="rect">
-            <a:avLst/>
-          </a:prstGeom>
-          <a:noFill/>
-        </p:spPr>
-        <p:txBody>
-          <a:bodyPr wrap="square">
-            <a:spAutoFit/>
-          </a:bodyPr>
-          <a:lstStyle/>
-          <a:p>
-            <a:pPr algn="l">
-              <a:spcAft>
-                <a:spcPts val="400"/>
-              </a:spcAft>
-            </a:pPr>
-            <a:r>
-              <a:rPr sz="1100" b="0">
-                <a:solidFill>
-                  <a:srgbClr val="5E6A7A"/>
-                </a:solidFill>
-              </a:rPr>
-              <a:t>Lập trình Web nâng cao · nộp 01/10/2026 · github.com/MMMAlonea04/AI_Web_Apps_Streamlit_React</a:t>
-            </a:r>
-          </a:p>
-        </p:txBody>
-      </p:sp>
-      <p:sp>
-        <p:nvSpPr>
-          <p:cNvPr id="4" name="TextBox 3"/>
-          <p:cNvSpPr txBox="1"/>
-          <p:nvPr/>
-        </p:nvSpPr>
-        <p:spPr>
-          <a:xfrm>
-            <a:off x="457200" y="1280160"/>
-            <a:ext cx="5074920" cy="274320"/>
-          </a:xfrm>
-          <a:prstGeom prst="rect">
-            <a:avLst/>
-          </a:prstGeom>
-          <a:noFill/>
-        </p:spPr>
-        <p:txBody>
-          <a:bodyPr wrap="square">
-            <a:spAutoFit/>
-          </a:bodyPr>
-          <a:lstStyle/>
-          <a:p>
-            <a:pPr algn="l">
-              <a:spcAft>
-                <a:spcPts val="400"/>
-              </a:spcAft>
-            </a:pPr>
-            <a:r>
-              <a:rPr sz="1300" b="1">
-                <a:solidFill>
-                  <a:srgbClr val="0B6E99"/>
-                </a:solidFill>
-              </a:rPr>
-              <a:t>CÁCH LÀM</a:t>
-            </a:r>
-          </a:p>
-        </p:txBody>
-      </p:sp>
-      <p:sp>
-        <p:nvSpPr>
-          <p:cNvPr id="5" name="TextBox 4"/>
-          <p:cNvSpPr txBox="1"/>
-          <p:nvPr/>
-        </p:nvSpPr>
-        <p:spPr>
-          <a:xfrm>
-            <a:off x="457200" y="1600200"/>
-            <a:ext cx="5074920" cy="3017520"/>
-          </a:xfrm>
-          <a:prstGeom prst="rect">
-            <a:avLst/>
-          </a:prstGeom>
-          <a:noFill/>
-        </p:spPr>
-        <p:txBody>
-          <a:bodyPr wrap="square">
-            <a:spAutoFit/>
-          </a:bodyPr>
-          <a:lstStyle/>
-          <a:p>
-            <a:pPr algn="l">
-              <a:spcAft>
-                <a:spcPts val="700"/>
-              </a:spcAft>
-            </a:pPr>
-            <a:r>
-              <a:rPr sz="1050" b="0">
-                <a:solidFill>
-                  <a:srgbClr val="1B2433"/>
-                </a:solidFill>
-              </a:rPr>
-              <a:t>1.  Tách 3 tầng: core/ chỉ suy luận → api/ bọc thành HTTP → giao diện chỉ gọi API.</a:t>
-            </a:r>
-          </a:p>
-          <a:p>
-            <a:pPr algn="l">
-              <a:spcAft>
-                <a:spcPts val="700"/>
-              </a:spcAft>
-            </a:pPr>
-            <a:r>
-              <a:rPr sz="1050" b="0">
-                <a:solidFill>
-                  <a:srgbClr val="1B2433"/>
-                </a:solidFill>
-              </a:rPr>
-              <a:t>2.  Một nơi giữ mô hình: FastAPI nạp 4 mô hình một lần; Streamlit và React đều là client mỏng.</a:t>
-            </a:r>
-          </a:p>
-          <a:p>
-            <a:pPr algn="l">
-              <a:spcAft>
-                <a:spcPts val="700"/>
-              </a:spcAft>
-            </a:pPr>
-            <a:r>
-              <a:rPr sz="1050" b="0">
-                <a:solidFill>
-                  <a:srgbClr val="1B2433"/>
-                </a:solidFill>
-              </a:rPr>
-              <a:t>3.  Cấu hình bằng biến môi trường (config.py): đổi mô hình, bật/tắt mô hình, đổi ngưỡng — không sửa code.</a:t>
-            </a:r>
-          </a:p>
-          <a:p>
-            <a:pPr algn="l">
-              <a:spcAft>
-                <a:spcPts val="700"/>
-              </a:spcAft>
-            </a:pPr>
-            <a:r>
-              <a:rPr sz="1050" b="0">
-                <a:solidFill>
-                  <a:srgbClr val="1B2433"/>
-                </a:solidFill>
-              </a:rPr>
-              <a:t>4.  Sinh trọng số và chỉ mục trên Colab T4 rồi mang về repo; dữ liệu thô, node_modules và .venv được .gitignore lọc sạch.</a:t>
-            </a:r>
-          </a:p>
-          <a:p>
-            <a:pPr algn="l">
-              <a:spcAft>
-                <a:spcPts val="700"/>
-              </a:spcAft>
-            </a:pPr>
-            <a:r>
-              <a:rPr sz="1050" b="0">
-                <a:solidFill>
-                  <a:srgbClr val="1B2433"/>
-                </a:solidFill>
-              </a:rPr>
-              <a:t>5.  Đo trước khi nộp: mỗi mô hình lưu metrics.json; độ trễ lấy từ header X-Process-Time-ms.</a:t>
-            </a:r>
-          </a:p>
-          <a:p>
-            <a:pPr algn="l">
-              <a:spcAft>
-                <a:spcPts val="700"/>
-              </a:spcAft>
-            </a:pPr>
-            <a:r>
-              <a:rPr sz="1050" b="0">
-                <a:solidFill>
-                  <a:srgbClr val="1B2433"/>
-                </a:solidFill>
-              </a:rPr>
-              <a:t>6.  Mọi bước chạy lại được bằng script: build_artifacts.py, serve.py, pytest.</a:t>
-            </a:r>
-          </a:p>
-        </p:txBody>
-      </p:sp>
-      <p:sp>
-        <p:nvSpPr>
-          <p:cNvPr id="6" name="TextBox 5"/>
-          <p:cNvSpPr txBox="1"/>
-          <p:nvPr/>
-        </p:nvSpPr>
-        <p:spPr>
-          <a:xfrm>
-            <a:off x="457200" y="4709160"/>
-            <a:ext cx="5074920" cy="274320"/>
-          </a:xfrm>
-          <a:prstGeom prst="rect">
-            <a:avLst/>
-          </a:prstGeom>
-          <a:noFill/>
-        </p:spPr>
-        <p:txBody>
-          <a:bodyPr wrap="square">
-            <a:spAutoFit/>
-          </a:bodyPr>
-          <a:lstStyle/>
-          <a:p>
-            <a:pPr algn="l">
-              <a:spcAft>
-                <a:spcPts val="400"/>
-              </a:spcAft>
-            </a:pPr>
-            <a:r>
-              <a:rPr sz="1300" b="1">
-                <a:solidFill>
-                  <a:srgbClr val="0B6E99"/>
-                </a:solidFill>
-              </a:rPr>
-              <a:t>KIẾN TRÚC</a:t>
-            </a:r>
-          </a:p>
-        </p:txBody>
-      </p:sp>
-      <p:sp>
-        <p:nvSpPr>
-          <p:cNvPr id="7" name="TextBox 6"/>
-          <p:cNvSpPr txBox="1"/>
-          <p:nvPr/>
-        </p:nvSpPr>
-        <p:spPr>
-          <a:xfrm>
-            <a:off x="457200" y="5010912"/>
-            <a:ext cx="5074920" cy="1371600"/>
-          </a:xfrm>
-          <a:prstGeom prst="rect">
-            <a:avLst/>
-          </a:prstGeom>
-          <a:noFill/>
-        </p:spPr>
-        <p:txBody>
-          <a:bodyPr wrap="square">
-            <a:spAutoFit/>
-          </a:bodyPr>
-          <a:lstStyle/>
-          <a:p>
-            <a:pPr algn="l">
-              <a:spcAft>
-                <a:spcPts val="200"/>
-              </a:spcAft>
-            </a:pPr>
-            <a:r>
-              <a:rPr sz="950" b="0">
-                <a:solidFill>
-                  <a:srgbClr val="5E6A7A"/>
-                </a:solidFill>
-              </a:rPr>
-              <a:t>Trình duyệt → Streamlit (8501) ─┐</a:t>
-            </a:r>
-          </a:p>
-          <a:p>
-            <a:pPr algn="l">
-              <a:spcAft>
-                <a:spcPts val="200"/>
-              </a:spcAft>
-            </a:pPr>
-            <a:r>
-              <a:rPr sz="950" b="0">
-                <a:solidFill>
-                  <a:srgbClr val="5E6A7A"/>
-                </a:solidFill>
-              </a:rPr>
-              <a:t>                                ├→ FastAPI (8000) → core/ (4 mô hình)</a:t>
-            </a:r>
-          </a:p>
-          <a:p>
-            <a:pPr algn="l">
-              <a:spcAft>
-                <a:spcPts val="200"/>
-              </a:spcAft>
-            </a:pPr>
-            <a:r>
-              <a:rPr sz="950" b="0">
-                <a:solidFill>
-                  <a:srgbClr val="5E6A7A"/>
-                </a:solidFill>
-              </a:rPr>
-              <a:t>Trình duyệt → React (web/dist) ─┘</a:t>
-            </a:r>
-          </a:p>
-          <a:p>
-            <a:pPr algn="l">
-              <a:spcAft>
-                <a:spcPts val="200"/>
-              </a:spcAft>
-            </a:pPr>
-          </a:p>
-          <a:p>
-            <a:pPr algn="l">
-              <a:spcAft>
-                <a:spcPts val="200"/>
-              </a:spcAft>
-            </a:pPr>
-            <a:r>
-              <a:rPr sz="950" b="0">
-                <a:solidFill>
-                  <a:srgbClr val="5E6A7A"/>
-                </a:solidFill>
-              </a:rPr>
-              <a:t>Sau khi npm run build, FastAPI phục vụ luôn web/dist → một cổng, một link, không cần CORS.</a:t>
-            </a:r>
-          </a:p>
-        </p:txBody>
-      </p:sp>
-      <p:sp>
-        <p:nvSpPr>
-          <p:cNvPr id="8" name="TextBox 7"/>
-          <p:cNvSpPr txBox="1"/>
-          <p:nvPr/>
-        </p:nvSpPr>
-        <p:spPr>
-          <a:xfrm>
-            <a:off x="5897880" y="1280160"/>
-            <a:ext cx="5897880" cy="274320"/>
-          </a:xfrm>
-          <a:prstGeom prst="rect">
-            <a:avLst/>
-          </a:prstGeom>
-          <a:noFill/>
-        </p:spPr>
-        <p:txBody>
-          <a:bodyPr wrap="square">
-            <a:spAutoFit/>
-          </a:bodyPr>
-          <a:lstStyle/>
-          <a:p>
-            <a:pPr algn="l">
-              <a:spcAft>
-                <a:spcPts val="400"/>
-              </a:spcAft>
-            </a:pPr>
-            <a:r>
-              <a:rPr sz="1250" b="1">
-                <a:solidFill>
-                  <a:srgbClr val="0B6E99"/>
-                </a:solidFill>
-              </a:rPr>
-              <a:t>4 CHỨC NĂNG — đều chạy thật, kiểm chứng qua link công khai</a:t>
-            </a:r>
-          </a:p>
-        </p:txBody>
-      </p:sp>
-      <p:graphicFrame>
-        <p:nvGraphicFramePr>
-          <p:cNvPr id="9" name="Table 8"/>
-          <p:cNvGraphicFramePr>
-            <a:graphicFrameLocks noGrp="1"/>
-          </p:cNvGraphicFramePr>
-          <p:nvPr/>
-        </p:nvGraphicFramePr>
-        <p:xfrm>
-          <a:off x="5897880" y="1600200"/>
-          <a:ext cx="5897880" cy="1737360"/>
-        </p:xfrm>
-        <a:graphic>
-          <a:graphicData uri="http://schemas.openxmlformats.org/drawingml/2006/table">
-            <a:tbl>
-              <a:tblPr firstRow="1" bandRow="1">
-                <a:tableStyleId>{5C22544A-7EE6-4342-B048-85BDC9FD1C3A}</a:tableStyleId>
-              </a:tblPr>
-              <a:tblGrid>
-                <a:gridCol w="1783080"/>
-                <a:gridCol w="2103120"/>
-                <a:gridCol w="2011680"/>
-              </a:tblGrid>
-              <a:tr h="347472">
-                <a:tc>
-                  <a:txBody>
-                    <a:bodyPr/>
-                    <a:lstStyle/>
-                    <a:p>
-                      <a:r>
-                        <a:rPr sz="900" b="1">
-                          <a:solidFill>
-                            <a:srgbClr val="FFFFFF"/>
-                          </a:solidFill>
-                        </a:rPr>
-                        <a:t>Chức năng</a:t>
-                      </a:r>
-                    </a:p>
-                  </a:txBody>
-                  <a:tcPr marL="50800" marR="50800" marT="12700" marB="12700"/>
-                </a:tc>
-                <a:tc>
-                  <a:txBody>
-                    <a:bodyPr/>
-                    <a:lstStyle/>
-                    <a:p>
-                      <a:r>
-                        <a:rPr sz="900" b="1">
-                          <a:solidFill>
-                            <a:srgbClr val="FFFFFF"/>
-                          </a:solidFill>
-                        </a:rPr>
-                        <a:t>Mô hình</a:t>
-                      </a:r>
-                    </a:p>
-                  </a:txBody>
-                  <a:tcPr marL="50800" marR="50800" marT="12700" marB="12700"/>
-                </a:tc>
-                <a:tc>
-                  <a:txBody>
-                    <a:bodyPr/>
-                    <a:lstStyle/>
-                    <a:p>
-                      <a:r>
-                        <a:rPr sz="900" b="1">
-                          <a:solidFill>
-                            <a:srgbClr val="FFFFFF"/>
-                          </a:solidFill>
-                        </a:rPr>
-                        <a:t>Kết quả chạy thật</a:t>
-                      </a:r>
-                    </a:p>
-                  </a:txBody>
-                  <a:tcPr marL="50800" marR="50800" marT="12700" marB="12700"/>
-                </a:tc>
-              </a:tr>
-              <a:tr h="347472">
-                <a:tc>
-                  <a:txBody>
-                    <a:bodyPr/>
-                    <a:lstStyle/>
-                    <a:p>
-                      <a:r>
-                        <a:rPr sz="900" b="1">
-                          <a:solidFill>
-                            <a:srgbClr val="1B2433"/>
-                          </a:solidFill>
-                        </a:rPr>
-                        <a:t>1. Phân loại ảnh</a:t>
-                      </a:r>
-                    </a:p>
-                  </a:txBody>
-                  <a:tcPr marL="50800" marR="50800" marT="12700" marB="12700"/>
-                </a:tc>
-                <a:tc>
-                  <a:txBody>
-                    <a:bodyPr/>
-                    <a:lstStyle/>
-                    <a:p>
-                      <a:r>
-                        <a:rPr sz="900" b="0">
-                          <a:solidFill>
-                            <a:srgbClr val="1B2433"/>
-                          </a:solidFill>
-                        </a:rPr>
-                        <a:t>ResNet-18 fine-tune, 5 loài</a:t>
-                      </a:r>
-                    </a:p>
-                  </a:txBody>
-                  <a:tcPr marL="50800" marR="50800" marT="12700" marB="12700"/>
-                </a:tc>
-                <a:tc>
-                  <a:txBody>
-                    <a:bodyPr/>
-                    <a:lstStyle/>
-                    <a:p>
-                      <a:r>
-                        <a:rPr sz="900" b="0">
-                          <a:solidFill>
-                            <a:srgbClr val="1B2433"/>
-                          </a:solidFill>
-                        </a:rPr>
-                        <a:t>sunflowers 88.6% · 39 ms</a:t>
-                      </a:r>
-                    </a:p>
-                  </a:txBody>
-                  <a:tcPr marL="50800" marR="50800" marT="12700" marB="12700"/>
-                </a:tc>
-              </a:tr>
-              <a:tr h="347472">
-                <a:tc>
-                  <a:txBody>
-                    <a:bodyPr/>
-                    <a:lstStyle/>
-                    <a:p>
-                      <a:r>
-                        <a:rPr sz="900" b="1">
-                          <a:solidFill>
-                            <a:srgbClr val="1B2433"/>
-                          </a:solidFill>
-                        </a:rPr>
-                        <a:t>2. Phát hiện đối tượng</a:t>
-                      </a:r>
-                    </a:p>
-                  </a:txBody>
-                  <a:tcPr marL="50800" marR="50800" marT="12700" marB="12700"/>
-                </a:tc>
-                <a:tc>
-                  <a:txBody>
-                    <a:bodyPr/>
-                    <a:lstStyle/>
-                    <a:p>
-                      <a:r>
-                        <a:rPr sz="900" b="0">
-                          <a:solidFill>
-                            <a:srgbClr val="1B2433"/>
-                          </a:solidFill>
-                        </a:rPr>
-                        <a:t>YOLO11n, 80 lớp COCO</a:t>
-                      </a:r>
-                    </a:p>
-                  </a:txBody>
-                  <a:tcPr marL="50800" marR="50800" marT="12700" marB="12700"/>
-                </a:tc>
-                <a:tc>
-                  <a:txBody>
-                    <a:bodyPr/>
-                    <a:lstStyle/>
-                    <a:p>
-                      <a:r>
-                        <a:rPr sz="900" b="0">
-                          <a:solidFill>
-                            <a:srgbClr val="1B2433"/>
-                          </a:solidFill>
-                        </a:rPr>
-                        <a:t>bus:1, person:4 · 65 ms</a:t>
-                      </a:r>
-                    </a:p>
-                  </a:txBody>
-                  <a:tcPr marL="50800" marR="50800" marT="12700" marB="12700"/>
-                </a:tc>
-              </a:tr>
-              <a:tr h="347472">
-                <a:tc>
-                  <a:txBody>
-                    <a:bodyPr/>
-                    <a:lstStyle/>
-                    <a:p>
-                      <a:r>
-                        <a:rPr sz="900" b="1">
-                          <a:solidFill>
-                            <a:srgbClr val="1B2433"/>
-                          </a:solidFill>
-                        </a:rPr>
-                        <a:t>3. Tìm kiếm ảnh</a:t>
-                      </a:r>
-                    </a:p>
-                  </a:txBody>
-                  <a:tcPr marL="50800" marR="50800" marT="12700" marB="12700"/>
-                </a:tc>
-                <a:tc>
-                  <a:txBody>
-                    <a:bodyPr/>
-                    <a:lstStyle/>
-                    <a:p>
-                      <a:r>
-                        <a:rPr sz="900" b="0">
-                          <a:solidFill>
-                            <a:srgbClr val="1B2433"/>
-                          </a:solidFill>
-                        </a:rPr>
-                        <a:t>CLIP ViT-B/32 + FAISS</a:t>
-                      </a:r>
-                    </a:p>
-                  </a:txBody>
-                  <a:tcPr marL="50800" marR="50800" marT="12700" marB="12700"/>
-                </a:tc>
-                <a:tc>
-                  <a:txBody>
-                    <a:bodyPr/>
-                    <a:lstStyle/>
-                    <a:p>
-                      <a:r>
-                        <a:rPr sz="900" b="0">
-                          <a:solidFill>
-                            <a:srgbClr val="1B2433"/>
-                          </a:solidFill>
-                        </a:rPr>
-                        <a:t>5/5 đúng loài · 20 ms</a:t>
-                      </a:r>
-                    </a:p>
-                  </a:txBody>
-                  <a:tcPr marL="50800" marR="50800" marT="12700" marB="12700"/>
-                </a:tc>
-              </a:tr>
-              <a:tr h="347472">
-                <a:tc>
-                  <a:txBody>
-                    <a:bodyPr/>
-                    <a:lstStyle/>
-                    <a:p>
-                      <a:r>
-                        <a:rPr sz="900" b="1">
-                          <a:solidFill>
-                            <a:srgbClr val="1B2433"/>
-                          </a:solidFill>
-                        </a:rPr>
-                        <a:t>4. Chatbot RAG</a:t>
-                      </a:r>
-                    </a:p>
-                  </a:txBody>
-                  <a:tcPr marL="50800" marR="50800" marT="12700" marB="12700"/>
-                </a:tc>
-                <a:tc>
-                  <a:txBody>
-                    <a:bodyPr/>
-                    <a:lstStyle/>
-                    <a:p>
-                      <a:r>
-                        <a:rPr sz="900" b="0">
-                          <a:solidFill>
-                            <a:srgbClr val="1B2433"/>
-                          </a:solidFill>
-                        </a:rPr>
-                        <a:t>Qwen2.5 + MiniLM + FAISS</a:t>
-                      </a:r>
-                    </a:p>
-                  </a:txBody>
-                  <a:tcPr marL="50800" marR="50800" marT="12700" marB="12700"/>
-                </a:tc>
-                <a:tc>
-                  <a:txBody>
-                    <a:bodyPr/>
-                    <a:lstStyle/>
-                    <a:p>
-                      <a:r>
-                        <a:rPr sz="900" b="0">
-                          <a:solidFill>
-                            <a:srgbClr val="1B2433"/>
-                          </a:solidFill>
-                        </a:rPr>
-                        <a:t>truy xuất 10/10 đúng tài liệu · 3,1 s</a:t>
-                      </a:r>
-                    </a:p>
-                  </a:txBody>
-                  <a:tcPr marL="50800" marR="50800" marT="12700" marB="12700"/>
-                </a:tc>
-              </a:tr>
-            </a:tbl>
-          </a:graphicData>
-        </a:graphic>
-      </p:graphicFrame>
-      <p:sp>
-        <p:nvSpPr>
-          <p:cNvPr id="10" name="TextBox 9"/>
-          <p:cNvSpPr txBox="1"/>
-          <p:nvPr/>
-        </p:nvSpPr>
-        <p:spPr>
-          <a:xfrm>
-            <a:off x="5897880" y="3611880"/>
-            <a:ext cx="5897880" cy="2468880"/>
-          </a:xfrm>
-          <a:prstGeom prst="rect">
-            <a:avLst/>
-          </a:prstGeom>
-          <a:noFill/>
-        </p:spPr>
-        <p:txBody>
-          <a:bodyPr wrap="square">
-            <a:spAutoFit/>
-          </a:bodyPr>
-          <a:lstStyle/>
-          <a:p>
-            <a:pPr algn="l">
-              <a:spcAft>
-                <a:spcPts val="300"/>
-              </a:spcAft>
-            </a:pPr>
-            <a:r>
-              <a:rPr sz="1000" b="0">
-                <a:solidFill>
-                  <a:srgbClr val="1B2433"/>
-                </a:solidFill>
-              </a:rPr>
-              <a:t>ĐỘ TRỄ ĐO TRÊN COLAB T4 (p50 / p95, phía server)</a:t>
-            </a:r>
-          </a:p>
-          <a:p>
-            <a:pPr algn="l">
-              <a:spcAft>
-                <a:spcPts val="300"/>
-              </a:spcAft>
-            </a:pPr>
-            <a:r>
-              <a:rPr sz="1000" b="0">
-                <a:solidFill>
-                  <a:srgbClr val="1B2433"/>
-                </a:solidFill>
-              </a:rPr>
-              <a:t>     Phân loại ảnh          39 / 71 ms</a:t>
-            </a:r>
-          </a:p>
-          <a:p>
-            <a:pPr algn="l">
-              <a:spcAft>
-                <a:spcPts val="300"/>
-              </a:spcAft>
-            </a:pPr>
-            <a:r>
-              <a:rPr sz="1000" b="0">
-                <a:solidFill>
-                  <a:srgbClr val="1B2433"/>
-                </a:solidFill>
-              </a:rPr>
-              <a:t>     Phát hiện đối tượng    65 / 88 ms</a:t>
-            </a:r>
-          </a:p>
-          <a:p>
-            <a:pPr algn="l">
-              <a:spcAft>
-                <a:spcPts val="300"/>
-              </a:spcAft>
-            </a:pPr>
-            <a:r>
-              <a:rPr sz="1000" b="0">
-                <a:solidFill>
-                  <a:srgbClr val="1B2433"/>
-                </a:solidFill>
-              </a:rPr>
-              <a:t>     Tìm ảnh bằng chữ        20 / 37 ms</a:t>
-            </a:r>
-          </a:p>
-          <a:p>
-            <a:pPr algn="l">
-              <a:spcAft>
-                <a:spcPts val="300"/>
-              </a:spcAft>
-            </a:pPr>
-            <a:r>
-              <a:rPr sz="1000" b="0">
-                <a:solidFill>
-                  <a:srgbClr val="1B2433"/>
-                </a:solidFill>
-              </a:rPr>
-              <a:t>     Tìm ảnh bằng ảnh        44 / 66 ms</a:t>
-            </a:r>
-          </a:p>
-          <a:p>
-            <a:pPr algn="l">
-              <a:spcAft>
-                <a:spcPts val="300"/>
-              </a:spcAft>
-            </a:pPr>
-            <a:r>
-              <a:rPr sz="1000" b="0">
-                <a:solidFill>
-                  <a:srgbClr val="1B2433"/>
-                </a:solidFill>
-              </a:rPr>
-              <a:t>     Chatbot             3.105 / 4.728 ms</a:t>
-            </a:r>
-          </a:p>
-          <a:p>
-            <a:pPr algn="l">
-              <a:spcAft>
-                <a:spcPts val="300"/>
-              </a:spcAft>
-            </a:pPr>
-          </a:p>
-          <a:p>
-            <a:pPr algn="l">
-              <a:spcAft>
-                <a:spcPts val="300"/>
-              </a:spcAft>
-            </a:pPr>
-            <a:r>
-              <a:rPr sz="1000" b="0">
-                <a:solidFill>
-                  <a:srgbClr val="1B2433"/>
-                </a:solidFill>
-              </a:rPr>
-              <a:t>Nút cổ chai là tunnel Cloudflare, không phải mô hình:</a:t>
-            </a:r>
-          </a:p>
-          <a:p>
-            <a:pPr algn="l">
-              <a:spcAft>
-                <a:spcPts val="300"/>
-              </a:spcAft>
-            </a:pPr>
-            <a:r>
-              <a:rPr sz="1000" b="0">
-                <a:solidFill>
-                  <a:srgbClr val="1B2433"/>
-                </a:solidFill>
-              </a:rPr>
-              <a:t>vòng-trip 559 ms trong khi server chỉ xử lý 39 ms.</a:t>
-            </a:r>
-          </a:p>
-          <a:p>
-            <a:pPr algn="l">
-              <a:spcAft>
-                <a:spcPts val="300"/>
-              </a:spcAft>
-            </a:pPr>
-            <a:r>
-              <a:rPr sz="1000" b="0">
-                <a:solidFill>
-                  <a:srgbClr val="1B2433"/>
-                </a:solidFill>
-              </a:rPr>
-              <a:t>Phát hiện trả ảnh base64 ~368 KB nên vòng-trip chậm hơn hẳn.</a:t>
-            </a:r>
-          </a:p>
-        </p:txBody>
-      </p:sp>
-      <p:sp>
-        <p:nvSpPr>
-          <p:cNvPr id="11" name="Rectangle 10"/>
-          <p:cNvSpPr/>
-          <p:nvPr/>
-        </p:nvSpPr>
-        <p:spPr>
-          <a:xfrm>
-            <a:off x="457200" y="6309360"/>
-            <a:ext cx="11338560" cy="457200"/>
+            <a:off x="0" y="0"/>
+            <a:ext cx="12191695" cy="54864"/>
           </a:xfrm>
           <a:prstGeom prst="rect">
             <a:avLst/>
           </a:prstGeom>
           <a:solidFill>
-            <a:srgbClr val="EEF3F6"/>
+            <a:srgbClr val="0B6E99"/>
           </a:solidFill>
           <a:ln>
             <a:noFill/>
           </a:ln>
+          <a:effectLst/>
         </p:spPr>
         <p:style>
           <a:lnRef idx="1">
@@ -3983,14 +3134,14 @@
       </p:sp>
       <p:sp>
         <p:nvSpPr>
-          <p:cNvPr id="12" name="TextBox 11"/>
+          <p:cNvPr id="3" name="TextBox 2"/>
           <p:cNvSpPr txBox="1"/>
           <p:nvPr/>
         </p:nvSpPr>
         <p:spPr>
           <a:xfrm>
-            <a:off x="566928" y="6364224"/>
-            <a:ext cx="11155680" cy="365760"/>
+            <a:off x="457200" y="256032"/>
+            <a:ext cx="11338560" cy="457200"/>
           </a:xfrm>
           <a:prstGeom prst="rect">
             <a:avLst/>
@@ -4005,31 +3156,802 @@
           <a:p>
             <a:pPr algn="l">
               <a:spcAft>
-                <a:spcPts val="100"/>
+                <a:spcPts val="500"/>
               </a:spcAft>
             </a:pPr>
             <a:r>
-              <a:rPr sz="850" b="0">
-                <a:solidFill>
-                  <a:srgbClr val="5E6A7A"/>
+              <a:rPr sz="2200" b="1">
+                <a:solidFill>
+                  <a:srgbClr val="0B6E99"/>
                 </a:solidFill>
               </a:rPr>
-              <a:t>AI hỗ trợ làm bài: Kimi Code CLI (Moonshot AI), mô hình deepseek-flash.</a:t>
-            </a:r>
-          </a:p>
+              <a:t>Cách làm — 3 tầng, 5 bước, 4 chức năng chạy thật</a:t>
+            </a:r>
+          </a:p>
+        </p:txBody>
+      </p:sp>
+      <p:sp>
+        <p:nvSpPr>
+          <p:cNvPr id="4" name="TextBox 3"/>
+          <p:cNvSpPr txBox="1"/>
+          <p:nvPr/>
+        </p:nvSpPr>
+        <p:spPr>
+          <a:xfrm>
+            <a:off x="457200" y="758952"/>
+            <a:ext cx="11338560" cy="274320"/>
+          </a:xfrm>
+          <a:prstGeom prst="rect">
+            <a:avLst/>
+          </a:prstGeom>
+          <a:noFill/>
+        </p:spPr>
+        <p:txBody>
+          <a:bodyPr wrap="square">
+            <a:spAutoFit/>
+          </a:bodyPr>
+          <a:lstStyle/>
           <a:p>
             <a:pPr algn="l">
               <a:spcAft>
-                <a:spcPts val="100"/>
+                <a:spcPts val="500"/>
               </a:spcAft>
             </a:pPr>
             <a:r>
-              <a:rPr sz="850" b="0">
+              <a:rPr sz="1100" b="0">
                 <a:solidFill>
                   <a:srgbClr val="5E6A7A"/>
                 </a:solidFill>
               </a:rPr>
-              <a:t>Mô hình trong sản phẩm: ResNet-18 · YOLO11n 8.4.165 (AGPL-3.0) · CLIP ViT-B/32 · MiniLM-L12-v2 · Qwen2.5-1.5B-Instruct.</a:t>
+              <a:t>AI Web Apps · Lập trình Web nâng cao · nộp 01/10/2026 · github.com/MMMAlonea04/AI_Web_Apps_Streamlit_React</a:t>
+            </a:r>
+          </a:p>
+        </p:txBody>
+      </p:sp>
+      <p:sp>
+        <p:nvSpPr>
+          <p:cNvPr id="5" name="TextBox 4"/>
+          <p:cNvSpPr txBox="1"/>
+          <p:nvPr/>
+        </p:nvSpPr>
+        <p:spPr>
+          <a:xfrm>
+            <a:off x="457200" y="1188720"/>
+            <a:ext cx="5669280" cy="274320"/>
+          </a:xfrm>
+          <a:prstGeom prst="rect">
+            <a:avLst/>
+          </a:prstGeom>
+          <a:noFill/>
+        </p:spPr>
+        <p:txBody>
+          <a:bodyPr wrap="square">
+            <a:spAutoFit/>
+          </a:bodyPr>
+          <a:lstStyle/>
+          <a:p>
+            <a:pPr algn="l">
+              <a:spcAft>
+                <a:spcPts val="500"/>
+              </a:spcAft>
+            </a:pPr>
+            <a:r>
+              <a:rPr sz="1300" b="1">
+                <a:solidFill>
+                  <a:srgbClr val="0B6E99"/>
+                </a:solidFill>
+              </a:rPr>
+              <a:t>CÁCH LÀM</a:t>
+            </a:r>
+          </a:p>
+        </p:txBody>
+      </p:sp>
+      <p:sp>
+        <p:nvSpPr>
+          <p:cNvPr id="6" name="TextBox 5"/>
+          <p:cNvSpPr txBox="1"/>
+          <p:nvPr/>
+        </p:nvSpPr>
+        <p:spPr>
+          <a:xfrm>
+            <a:off x="457200" y="1536192"/>
+            <a:ext cx="5669280" cy="3200400"/>
+          </a:xfrm>
+          <a:prstGeom prst="rect">
+            <a:avLst/>
+          </a:prstGeom>
+          <a:noFill/>
+        </p:spPr>
+        <p:txBody>
+          <a:bodyPr wrap="square">
+            <a:spAutoFit/>
+          </a:bodyPr>
+          <a:lstStyle/>
+          <a:p>
+            <a:pPr algn="l">
+              <a:spcAft>
+                <a:spcPts val="700"/>
+              </a:spcAft>
+            </a:pPr>
+            <a:r>
+              <a:rPr sz="1050" b="0">
+                <a:solidFill>
+                  <a:srgbClr val="1B2433"/>
+                </a:solidFill>
+              </a:rPr>
+              <a:t>1.  Tách 3 tầng: core/ chỉ suy luận → api/ bọc HTTP → giao diện chỉ gọi API.</a:t>
+            </a:r>
+          </a:p>
+          <a:p>
+            <a:pPr algn="l">
+              <a:spcAft>
+                <a:spcPts val="700"/>
+              </a:spcAft>
+            </a:pPr>
+            <a:r>
+              <a:rPr sz="1050" b="0">
+                <a:solidFill>
+                  <a:srgbClr val="1B2433"/>
+                </a:solidFill>
+              </a:rPr>
+              <a:t>2.  Một nơi giữ mô hình: FastAPI nạp 4 mô hình một lần; Streamlit và React đều là client mỏng.</a:t>
+            </a:r>
+          </a:p>
+          <a:p>
+            <a:pPr algn="l">
+              <a:spcAft>
+                <a:spcPts val="700"/>
+              </a:spcAft>
+            </a:pPr>
+            <a:r>
+              <a:rPr sz="1050" b="0">
+                <a:solidFill>
+                  <a:srgbClr val="1B2433"/>
+                </a:solidFill>
+              </a:rPr>
+              <a:t>3.  Cấu hình bằng biến môi trường (config.py): đổi mô hình, bật/tắt mô hình, đổi ngưỡng — không sửa code.</a:t>
+            </a:r>
+          </a:p>
+          <a:p>
+            <a:pPr algn="l">
+              <a:spcAft>
+                <a:spcPts val="700"/>
+              </a:spcAft>
+            </a:pPr>
+            <a:r>
+              <a:rPr sz="1050" b="0">
+                <a:solidFill>
+                  <a:srgbClr val="1B2433"/>
+                </a:solidFill>
+              </a:rPr>
+              <a:t>4.  Sinh trọng số và chỉ mục trên Colab T4 (build_artifacts.py, 5 stage cố định) rồi mang về repo.</a:t>
+            </a:r>
+          </a:p>
+          <a:p>
+            <a:pPr algn="l">
+              <a:spcAft>
+                <a:spcPts val="700"/>
+              </a:spcAft>
+            </a:pPr>
+            <a:r>
+              <a:rPr sz="1050" b="0">
+                <a:solidFill>
+                  <a:srgbClr val="1B2433"/>
+                </a:solidFill>
+              </a:rPr>
+              <a:t>5.  Đo trước khi nộp: mỗi mô hình lưu metrics.json; độ trễ lấy từ header X-Process-Time-ms.</a:t>
+            </a:r>
+          </a:p>
+          <a:p>
+            <a:pPr algn="l">
+              <a:spcAft>
+                <a:spcPts val="700"/>
+              </a:spcAft>
+            </a:pPr>
+            <a:r>
+              <a:rPr sz="1050" b="0">
+                <a:solidFill>
+                  <a:srgbClr val="1B2433"/>
+                </a:solidFill>
+              </a:rPr>
+              <a:t>6.  Kiểm thử: 7 test pytest chạy 0,4 giây không cần GPU.</a:t>
+            </a:r>
+          </a:p>
+        </p:txBody>
+      </p:sp>
+      <p:sp>
+        <p:nvSpPr>
+          <p:cNvPr id="7" name="TextBox 6"/>
+          <p:cNvSpPr txBox="1"/>
+          <p:nvPr/>
+        </p:nvSpPr>
+        <p:spPr>
+          <a:xfrm>
+            <a:off x="457200" y="4709160"/>
+            <a:ext cx="5669280" cy="274320"/>
+          </a:xfrm>
+          <a:prstGeom prst="rect">
+            <a:avLst/>
+          </a:prstGeom>
+          <a:noFill/>
+        </p:spPr>
+        <p:txBody>
+          <a:bodyPr wrap="square">
+            <a:spAutoFit/>
+          </a:bodyPr>
+          <a:lstStyle/>
+          <a:p>
+            <a:pPr algn="l">
+              <a:spcAft>
+                <a:spcPts val="500"/>
+              </a:spcAft>
+            </a:pPr>
+            <a:r>
+              <a:rPr sz="1300" b="1">
+                <a:solidFill>
+                  <a:srgbClr val="0B6E99"/>
+                </a:solidFill>
+              </a:rPr>
+              <a:t>KIẾN TRÚC</a:t>
+            </a:r>
+          </a:p>
+        </p:txBody>
+      </p:sp>
+      <p:sp>
+        <p:nvSpPr>
+          <p:cNvPr id="8" name="TextBox 7"/>
+          <p:cNvSpPr txBox="1"/>
+          <p:nvPr/>
+        </p:nvSpPr>
+        <p:spPr>
+          <a:xfrm>
+            <a:off x="457200" y="5029200"/>
+            <a:ext cx="5669280" cy="1188720"/>
+          </a:xfrm>
+          <a:prstGeom prst="rect">
+            <a:avLst/>
+          </a:prstGeom>
+          <a:noFill/>
+        </p:spPr>
+        <p:txBody>
+          <a:bodyPr wrap="square">
+            <a:spAutoFit/>
+          </a:bodyPr>
+          <a:lstStyle/>
+          <a:p>
+            <a:pPr algn="l">
+              <a:spcAft>
+                <a:spcPts val="200"/>
+              </a:spcAft>
+            </a:pPr>
+            <a:r>
+              <a:rPr sz="950" b="0">
+                <a:solidFill>
+                  <a:srgbClr val="5E6A7A"/>
+                </a:solidFill>
+              </a:rPr>
+              <a:t>Trình duyệt → Streamlit (8501) ─┐</a:t>
+            </a:r>
+          </a:p>
+          <a:p>
+            <a:pPr algn="l">
+              <a:spcAft>
+                <a:spcPts val="200"/>
+              </a:spcAft>
+            </a:pPr>
+            <a:r>
+              <a:rPr sz="950" b="0">
+                <a:solidFill>
+                  <a:srgbClr val="5E6A7A"/>
+                </a:solidFill>
+              </a:rPr>
+              <a:t>                                ├→ FastAPI (8000) → core/ (4 mô hình)</a:t>
+            </a:r>
+          </a:p>
+          <a:p>
+            <a:pPr algn="l">
+              <a:spcAft>
+                <a:spcPts val="200"/>
+              </a:spcAft>
+            </a:pPr>
+            <a:r>
+              <a:rPr sz="950" b="0">
+                <a:solidFill>
+                  <a:srgbClr val="5E6A7A"/>
+                </a:solidFill>
+              </a:rPr>
+              <a:t>Trình duyệt → React (web/dist) ─┘</a:t>
+            </a:r>
+          </a:p>
+          <a:p>
+            <a:pPr algn="l">
+              <a:spcAft>
+                <a:spcPts val="200"/>
+              </a:spcAft>
+            </a:pPr>
+            <a:r>
+              <a:rPr sz="950" b="0">
+                <a:solidFill>
+                  <a:srgbClr val="5E6A7A"/>
+                </a:solidFill>
+              </a:rPr>
+              <a:t>Sau khi build React: một cổng, một link, không cần CORS.</a:t>
+            </a:r>
+          </a:p>
+        </p:txBody>
+      </p:sp>
+      <p:sp>
+        <p:nvSpPr>
+          <p:cNvPr id="9" name="TextBox 8"/>
+          <p:cNvSpPr txBox="1"/>
+          <p:nvPr/>
+        </p:nvSpPr>
+        <p:spPr>
+          <a:xfrm>
+            <a:off x="6309360" y="1188720"/>
+            <a:ext cx="5440680" cy="274320"/>
+          </a:xfrm>
+          <a:prstGeom prst="rect">
+            <a:avLst/>
+          </a:prstGeom>
+          <a:noFill/>
+        </p:spPr>
+        <p:txBody>
+          <a:bodyPr wrap="square">
+            <a:spAutoFit/>
+          </a:bodyPr>
+          <a:lstStyle/>
+          <a:p>
+            <a:pPr algn="l">
+              <a:spcAft>
+                <a:spcPts val="500"/>
+              </a:spcAft>
+            </a:pPr>
+            <a:r>
+              <a:rPr sz="1300" b="1">
+                <a:solidFill>
+                  <a:srgbClr val="0B6E99"/>
+                </a:solidFill>
+              </a:rPr>
+              <a:t>4 CHỨC NĂNG + SỐ ĐO</a:t>
+            </a:r>
+          </a:p>
+        </p:txBody>
+      </p:sp>
+      <p:graphicFrame>
+        <p:nvGraphicFramePr>
+          <p:cNvPr id="10" name="Table 9"/>
+          <p:cNvGraphicFramePr>
+            <a:graphicFrameLocks noGrp="1"/>
+          </p:cNvGraphicFramePr>
+          <p:nvPr/>
+        </p:nvGraphicFramePr>
+        <p:xfrm>
+          <a:off x="6309360" y="1536192"/>
+          <a:ext cx="5440680" cy="1554480"/>
+        </p:xfrm>
+        <a:graphic>
+          <a:graphicData uri="http://schemas.openxmlformats.org/drawingml/2006/table">
+            <a:tbl>
+              <a:tblPr firstRow="1" bandRow="1">
+                <a:tableStyleId>{5C22544A-7EE6-4342-B048-85BDC9FD1C3A}</a:tableStyleId>
+              </a:tblPr>
+              <a:tblGrid>
+                <a:gridCol w="2743200"/>
+                <a:gridCol w="2697480"/>
+              </a:tblGrid>
+              <a:tr h="310896">
+                <a:tc>
+                  <a:txBody>
+                    <a:bodyPr/>
+                    <a:lstStyle/>
+                    <a:p>
+                      <a:r>
+                        <a:rPr sz="950" b="1">
+                          <a:solidFill>
+                            <a:srgbClr val="FFFFFF"/>
+                          </a:solidFill>
+                        </a:rPr>
+                        <a:t>Chức năng</a:t>
+                      </a:r>
+                    </a:p>
+                  </a:txBody>
+                  <a:tcPr marL="63500" marR="63500" marT="25400" marB="25400" anchor="ctr"/>
+                </a:tc>
+                <a:tc>
+                  <a:txBody>
+                    <a:bodyPr/>
+                    <a:lstStyle/>
+                    <a:p>
+                      <a:r>
+                        <a:rPr sz="950" b="1">
+                          <a:solidFill>
+                            <a:srgbClr val="FFFFFF"/>
+                          </a:solidFill>
+                        </a:rPr>
+                        <a:t>Số đo thực tế</a:t>
+                      </a:r>
+                    </a:p>
+                  </a:txBody>
+                  <a:tcPr marL="63500" marR="63500" marT="25400" marB="25400" anchor="ctr"/>
+                </a:tc>
+              </a:tr>
+              <a:tr h="310896">
+                <a:tc>
+                  <a:txBody>
+                    <a:bodyPr/>
+                    <a:lstStyle/>
+                    <a:p>
+                      <a:r>
+                        <a:rPr sz="950" b="1">
+                          <a:solidFill>
+                            <a:srgbClr val="1B2433"/>
+                          </a:solidFill>
+                        </a:rPr>
+                        <a:t>1. Phân loại ảnh</a:t>
+                      </a:r>
+                    </a:p>
+                  </a:txBody>
+                  <a:tcPr marL="63500" marR="63500" marT="25400" marB="25400" anchor="ctr"/>
+                </a:tc>
+                <a:tc>
+                  <a:txBody>
+                    <a:bodyPr/>
+                    <a:lstStyle/>
+                    <a:p>
+                      <a:r>
+                        <a:rPr sz="950" b="0">
+                          <a:solidFill>
+                            <a:srgbClr val="1B2433"/>
+                          </a:solidFill>
+                        </a:rPr>
+                        <a:t>accuracy 0.9510 · 39 ms</a:t>
+                      </a:r>
+                    </a:p>
+                  </a:txBody>
+                  <a:tcPr marL="63500" marR="63500" marT="25400" marB="25400" anchor="ctr"/>
+                </a:tc>
+              </a:tr>
+              <a:tr h="310896">
+                <a:tc>
+                  <a:txBody>
+                    <a:bodyPr/>
+                    <a:lstStyle/>
+                    <a:p>
+                      <a:r>
+                        <a:rPr sz="950" b="1">
+                          <a:solidFill>
+                            <a:srgbClr val="1B2433"/>
+                          </a:solidFill>
+                        </a:rPr>
+                        <a:t>2. Phát hiện đối tượng</a:t>
+                      </a:r>
+                    </a:p>
+                  </a:txBody>
+                  <a:tcPr marL="63500" marR="63500" marT="25400" marB="25400" anchor="ctr"/>
+                </a:tc>
+                <a:tc>
+                  <a:txBody>
+                    <a:bodyPr/>
+                    <a:lstStyle/>
+                    <a:p>
+                      <a:r>
+                        <a:rPr sz="950" b="0">
+                          <a:solidFill>
+                            <a:srgbClr val="1B2433"/>
+                          </a:solidFill>
+                        </a:rPr>
+                        <a:t>mAP50 0.6696 · 65 ms</a:t>
+                      </a:r>
+                    </a:p>
+                  </a:txBody>
+                  <a:tcPr marL="63500" marR="63500" marT="25400" marB="25400" anchor="ctr"/>
+                </a:tc>
+              </a:tr>
+              <a:tr h="310896">
+                <a:tc>
+                  <a:txBody>
+                    <a:bodyPr/>
+                    <a:lstStyle/>
+                    <a:p>
+                      <a:r>
+                        <a:rPr sz="950" b="1">
+                          <a:solidFill>
+                            <a:srgbClr val="1B2433"/>
+                          </a:solidFill>
+                        </a:rPr>
+                        <a:t>3. Tìm kiếm ảnh</a:t>
+                      </a:r>
+                    </a:p>
+                  </a:txBody>
+                  <a:tcPr marL="63500" marR="63500" marT="25400" marB="25400" anchor="ctr"/>
+                </a:tc>
+                <a:tc>
+                  <a:txBody>
+                    <a:bodyPr/>
+                    <a:lstStyle/>
+                    <a:p>
+                      <a:r>
+                        <a:rPr sz="950" b="0">
+                          <a:solidFill>
+                            <a:srgbClr val="1B2433"/>
+                          </a:solidFill>
+                        </a:rPr>
+                        <a:t>Precision@5 0.8760 · 20 ms</a:t>
+                      </a:r>
+                    </a:p>
+                  </a:txBody>
+                  <a:tcPr marL="63500" marR="63500" marT="25400" marB="25400" anchor="ctr"/>
+                </a:tc>
+              </a:tr>
+              <a:tr h="310896">
+                <a:tc>
+                  <a:txBody>
+                    <a:bodyPr/>
+                    <a:lstStyle/>
+                    <a:p>
+                      <a:r>
+                        <a:rPr sz="950" b="1">
+                          <a:solidFill>
+                            <a:srgbClr val="1B2433"/>
+                          </a:solidFill>
+                        </a:rPr>
+                        <a:t>4. Chatbot RAG</a:t>
+                      </a:r>
+                    </a:p>
+                  </a:txBody>
+                  <a:tcPr marL="63500" marR="63500" marT="25400" marB="25400" anchor="ctr"/>
+                </a:tc>
+                <a:tc>
+                  <a:txBody>
+                    <a:bodyPr/>
+                    <a:lstStyle/>
+                    <a:p>
+                      <a:r>
+                        <a:rPr sz="950" b="0">
+                          <a:solidFill>
+                            <a:srgbClr val="1B2433"/>
+                          </a:solidFill>
+                        </a:rPr>
+                        <a:t>Hit@1 1.00 · 3.105 ms</a:t>
+                      </a:r>
+                    </a:p>
+                  </a:txBody>
+                  <a:tcPr marL="63500" marR="63500" marT="25400" marB="25400" anchor="ctr"/>
+                </a:tc>
+              </a:tr>
+            </a:tbl>
+          </a:graphicData>
+        </a:graphic>
+      </p:graphicFrame>
+      <p:sp>
+        <p:nvSpPr>
+          <p:cNvPr id="11" name="TextBox 10"/>
+          <p:cNvSpPr txBox="1"/>
+          <p:nvPr/>
+        </p:nvSpPr>
+        <p:spPr>
+          <a:xfrm>
+            <a:off x="6309360" y="3337560"/>
+            <a:ext cx="5440680" cy="2286000"/>
+          </a:xfrm>
+          <a:prstGeom prst="rect">
+            <a:avLst/>
+          </a:prstGeom>
+          <a:noFill/>
+        </p:spPr>
+        <p:txBody>
+          <a:bodyPr wrap="square">
+            <a:spAutoFit/>
+          </a:bodyPr>
+          <a:lstStyle/>
+          <a:p>
+            <a:pPr algn="l">
+              <a:spcAft>
+                <a:spcPts val="200"/>
+              </a:spcAft>
+            </a:pPr>
+            <a:r>
+              <a:rPr sz="900" b="0">
+                <a:solidFill>
+                  <a:srgbClr val="1B2433"/>
+                </a:solidFill>
+              </a:rPr>
+              <a:t>KHAI BÁO AI ĐÃ DÙNG</a:t>
+            </a:r>
+          </a:p>
+          <a:p>
+            <a:pPr algn="l">
+              <a:spcAft>
+                <a:spcPts val="200"/>
+              </a:spcAft>
+            </a:pPr>
+            <a:r>
+              <a:rPr sz="900" b="0">
+                <a:solidFill>
+                  <a:srgbClr val="1B2433"/>
+                </a:solidFill>
+              </a:rPr>
+              <a:t>   Kimi Code CLI (Moonshot AI) — deepseek-flash</a:t>
+            </a:r>
+          </a:p>
+          <a:p>
+            <a:pPr algn="l">
+              <a:spcAft>
+                <a:spcPts val="200"/>
+              </a:spcAft>
+            </a:pPr>
+            <a:r>
+              <a:rPr sz="900" b="0">
+                <a:solidFill>
+                  <a:srgbClr val="1B2433"/>
+                </a:solidFill>
+              </a:rPr>
+              <a:t>   Mô hình trong sản phẩm: ResNet-18 · YOLO11n 8.4.165</a:t>
+            </a:r>
+          </a:p>
+          <a:p>
+            <a:pPr algn="l">
+              <a:spcAft>
+                <a:spcPts val="200"/>
+              </a:spcAft>
+            </a:pPr>
+            <a:r>
+              <a:rPr sz="900" b="0">
+                <a:solidFill>
+                  <a:srgbClr val="1B2433"/>
+                </a:solidFill>
+              </a:rPr>
+              <a:t>   (AGPL-3.0) · CLIP ViT-B/32 · MiniLM · Qwen2.5-1.5B</a:t>
+            </a:r>
+          </a:p>
+          <a:p>
+            <a:pPr algn="l">
+              <a:spcAft>
+                <a:spcPts val="200"/>
+              </a:spcAft>
+            </a:pPr>
+          </a:p>
+          <a:p>
+            <a:pPr algn="l">
+              <a:spcAft>
+                <a:spcPts val="200"/>
+              </a:spcAft>
+            </a:pPr>
+            <a:r>
+              <a:rPr sz="900" b="0">
+                <a:solidFill>
+                  <a:srgbClr val="1B2433"/>
+                </a:solidFill>
+              </a:rPr>
+              <a:t>HẠN CHẾ ĐÃ BIẾT</a:t>
+            </a:r>
+          </a:p>
+          <a:p>
+            <a:pPr algn="l">
+              <a:spcAft>
+                <a:spcPts val="200"/>
+              </a:spcAft>
+            </a:pPr>
+            <a:r>
+              <a:rPr sz="900" b="0">
+                <a:solidFill>
+                  <a:srgbClr val="1B2433"/>
+                </a:solidFill>
+              </a:rPr>
+              <a:t>   •  Gõ tiếng Việt không dấu làm truy xuất sai tài liệu.</a:t>
+            </a:r>
+          </a:p>
+          <a:p>
+            <a:pPr algn="l">
+              <a:spcAft>
+                <a:spcPts val="200"/>
+              </a:spcAft>
+            </a:pPr>
+            <a:r>
+              <a:rPr sz="900" b="0">
+                <a:solidFill>
+                  <a:srgbClr val="1B2433"/>
+                </a:solidFill>
+              </a:rPr>
+              <a:t>   •  mAP đo trên COCO128 — chính dữ liệu mô hình đã học.</a:t>
+            </a:r>
+          </a:p>
+          <a:p>
+            <a:pPr algn="l">
+              <a:spcAft>
+                <a:spcPts val="200"/>
+              </a:spcAft>
+            </a:pPr>
+            <a:r>
+              <a:rPr sz="900" b="0">
+                <a:solidFill>
+                  <a:srgbClr val="1B2433"/>
+                </a:solidFill>
+              </a:rPr>
+              <a:t>   •  API chưa có xác thực và giới hạn tần suất.</a:t>
+            </a:r>
+          </a:p>
+        </p:txBody>
+      </p:sp>
+      <p:sp>
+        <p:nvSpPr>
+          <p:cNvPr id="12" name="Rectangle 11"/>
+          <p:cNvSpPr/>
+          <p:nvPr/>
+        </p:nvSpPr>
+        <p:spPr>
+          <a:xfrm>
+            <a:off x="457200" y="6355080"/>
+            <a:ext cx="11292840" cy="384048"/>
+          </a:xfrm>
+          <a:prstGeom prst="rect">
+            <a:avLst/>
+          </a:prstGeom>
+          <a:solidFill>
+            <a:srgbClr val="EEF3F6"/>
+          </a:solidFill>
+          <a:ln>
+            <a:noFill/>
+          </a:ln>
+          <a:effectLst/>
+        </p:spPr>
+        <p:style>
+          <a:lnRef idx="1">
+            <a:schemeClr val="accent1"/>
+          </a:lnRef>
+          <a:fillRef idx="3">
+            <a:schemeClr val="accent1"/>
+          </a:fillRef>
+          <a:effectRef idx="2">
+            <a:schemeClr val="accent1"/>
+          </a:effectRef>
+          <a:fontRef idx="minor">
+            <a:schemeClr val="lt1"/>
+          </a:fontRef>
+        </p:style>
+        <p:txBody>
+          <a:bodyPr rtlCol="0" anchor="ctr"/>
+          <a:lstStyle/>
+          <a:p>
+            <a:pPr algn="ctr"/>
+          </a:p>
+        </p:txBody>
+      </p:sp>
+      <p:sp>
+        <p:nvSpPr>
+          <p:cNvPr id="13" name="TextBox 12"/>
+          <p:cNvSpPr txBox="1"/>
+          <p:nvPr/>
+        </p:nvSpPr>
+        <p:spPr>
+          <a:xfrm>
+            <a:off x="566928" y="6409944"/>
+            <a:ext cx="11064240" cy="292608"/>
+          </a:xfrm>
+          <a:prstGeom prst="rect">
+            <a:avLst/>
+          </a:prstGeom>
+          <a:noFill/>
+        </p:spPr>
+        <p:txBody>
+          <a:bodyPr wrap="square">
+            <a:spAutoFit/>
+          </a:bodyPr>
+          <a:lstStyle/>
+          <a:p>
+            <a:pPr algn="l">
+              <a:spcAft>
+                <a:spcPts val="500"/>
+              </a:spcAft>
+            </a:pPr>
+            <a:r>
+              <a:rPr sz="900" b="0">
+                <a:solidFill>
+                  <a:srgbClr val="5E6A7A"/>
+                </a:solidFill>
+              </a:rPr>
+              <a:t>Clone repo là chạy được ngay: đã kèm artifacts/ và data/gallery/  ·  github.com/MMMAlonea04/AI_Web_Apps_Streamlit_React</a:t>
             </a:r>
           </a:p>
         </p:txBody>

</xml_diff>